<commit_message>
Sửa lỗi tiêu đề slide hiện 'Click to add title'
<a:endParaRPr> phải là con cuối cùng của <a:p>. Hàm set_lines giữ lại
endParaRPr của paragraph mẫu rồi append run vào sau nó, nên PowerPoint
đọc paragraph là rỗng và hiện prompt của placeholder.

Giờ chỉ giữ <a:pPr>, thêm run, rồi mới append endParaRPr sau cùng.
Thêm check_paras.py để bắt lại lỗi thứ tự này (12 paragraph hỏng -> 0).

Co-Authored-By: Claude Opus 5 <noreply@anthropic.com>
Claude-Session: https://claude.ai/code/session_011byrCkBWXeuJWCjrTMvtrk
</commit_message>
<xml_diff>
--- a/slide/LPNVi_LONG_PRODUCTION_NAME_VIETNAMESE.pptx
+++ b/slide/LPNVi_LONG_PRODUCTION_NAME_VIETNAMESE.pptx
@@ -15348,19 +15348,19 @@
           <a:bodyPr/>
           <a:lstStyle/>
           <a:p>
+            <a:r>
+              <a:rPr lang="en-US" dirty="0">
+                <a:solidFill>
+                  <a:schemeClr val="tx1"/>
+                </a:solidFill>
+              </a:rPr>
+              <a:t>Tổng quan giải pháp</a:t>
+            </a:r>
             <a:endParaRPr lang="en-DE" dirty="0">
               <a:solidFill>
                 <a:schemeClr val="tx1"/>
               </a:solidFill>
             </a:endParaRPr>
-            <a:r>
-              <a:rPr lang="en-US" dirty="0">
-                <a:solidFill>
-                  <a:schemeClr val="tx1"/>
-                </a:solidFill>
-              </a:rPr>
-              <a:t>Tổng quan giải pháp</a:t>
-            </a:r>
           </a:p>
         </p:txBody>
       </p:sp>
@@ -16690,21 +16690,21 @@
           <a:lstStyle/>
           <a:p>
             <a:pPr algn="ctr"/>
+            <a:r>
+              <a:rPr lang="en-US" sz="1050" i="1" dirty="0">
+                <a:solidFill>
+                  <a:srgbClr val="6B6B6B"/>
+                </a:solidFill>
+                <a:latin typeface="Calibri"/>
+              </a:rPr>
+              <a:t>Tách separator "| "</a:t>
+            </a:r>
             <a:endParaRPr sz="1050" i="1" dirty="0">
               <a:solidFill>
                 <a:srgbClr val="6B6B6B"/>
               </a:solidFill>
               <a:latin typeface="Calibri"/>
             </a:endParaRPr>
-            <a:r>
-              <a:rPr lang="en-US" sz="1050" i="1" dirty="0">
-                <a:solidFill>
-                  <a:srgbClr val="6B6B6B"/>
-                </a:solidFill>
-                <a:latin typeface="Calibri"/>
-              </a:rPr>
-              <a:t>Tách separator "| "</a:t>
-            </a:r>
           </a:p>
         </p:txBody>
       </p:sp>
@@ -16908,19 +16908,19 @@
           <a:bodyPr/>
           <a:lstStyle/>
           <a:p>
+            <a:r>
+              <a:rPr lang="en-US">
+                <a:solidFill>
+                  <a:schemeClr val="tx1"/>
+                </a:solidFill>
+              </a:rPr>
+              <a:t>Hiện trạng</a:t>
+            </a:r>
             <a:endParaRPr lang="en-DE" dirty="0">
               <a:solidFill>
                 <a:schemeClr val="tx1"/>
               </a:solidFill>
             </a:endParaRPr>
-            <a:r>
-              <a:rPr lang="en-US">
-                <a:solidFill>
-                  <a:schemeClr val="tx1"/>
-                </a:solidFill>
-              </a:rPr>
-              <a:t>Hiện trạng</a:t>
-            </a:r>
           </a:p>
         </p:txBody>
       </p:sp>
@@ -16950,11 +16950,11 @@
           <a:bodyPr/>
           <a:lstStyle/>
           <a:p>
+            <a:r>
+              <a:rPr lang="en-US"/>
+              <a:t>1</a:t>
+            </a:r>
             <a:endParaRPr lang="en-DE" dirty="0"/>
-            <a:r>
-              <a:rPr lang="en-US"/>
-              <a:t>1</a:t>
-            </a:r>
           </a:p>
         </p:txBody>
       </p:sp>
@@ -17941,19 +17941,19 @@
           <a:bodyPr/>
           <a:lstStyle/>
           <a:p>
+            <a:r>
+              <a:rPr lang="en-US">
+                <a:solidFill>
+                  <a:schemeClr val="tx1"/>
+                </a:solidFill>
+              </a:rPr>
+              <a:t>Yêu cầu</a:t>
+            </a:r>
             <a:endParaRPr lang="en-DE" dirty="0">
               <a:solidFill>
                 <a:schemeClr val="tx1"/>
               </a:solidFill>
             </a:endParaRPr>
-            <a:r>
-              <a:rPr lang="en-US">
-                <a:solidFill>
-                  <a:schemeClr val="tx1"/>
-                </a:solidFill>
-              </a:rPr>
-              <a:t>Yêu cầu</a:t>
-            </a:r>
           </a:p>
         </p:txBody>
       </p:sp>
@@ -17983,11 +17983,11 @@
           <a:bodyPr/>
           <a:lstStyle/>
           <a:p>
+            <a:r>
+              <a:rPr lang="en-US"/>
+              <a:t>2</a:t>
+            </a:r>
             <a:endParaRPr lang="en-DE" dirty="0"/>
-            <a:r>
-              <a:rPr lang="en-US"/>
-              <a:t>2</a:t>
-            </a:r>
           </a:p>
         </p:txBody>
       </p:sp>
@@ -19104,19 +19104,19 @@
           <a:bodyPr/>
           <a:lstStyle/>
           <a:p>
+            <a:r>
+              <a:rPr lang="en-US">
+                <a:solidFill>
+                  <a:schemeClr val="tx1"/>
+                </a:solidFill>
+              </a:rPr>
+              <a:t>Giải pháp</a:t>
+            </a:r>
             <a:endParaRPr lang="en-DE" dirty="0">
               <a:solidFill>
                 <a:schemeClr val="tx1"/>
               </a:solidFill>
             </a:endParaRPr>
-            <a:r>
-              <a:rPr lang="en-US">
-                <a:solidFill>
-                  <a:schemeClr val="tx1"/>
-                </a:solidFill>
-              </a:rPr>
-              <a:t>Giải pháp</a:t>
-            </a:r>
           </a:p>
         </p:txBody>
       </p:sp>
@@ -19146,11 +19146,11 @@
           <a:bodyPr/>
           <a:lstStyle/>
           <a:p>
+            <a:r>
+              <a:rPr lang="en-US"/>
+              <a:t>3</a:t>
+            </a:r>
             <a:endParaRPr lang="en-DE" dirty="0"/>
-            <a:r>
-              <a:rPr lang="en-US"/>
-              <a:t>3</a:t>
-            </a:r>
           </a:p>
         </p:txBody>
       </p:sp>
@@ -20585,19 +20585,19 @@
           <a:bodyPr/>
           <a:lstStyle/>
           <a:p>
+            <a:r>
+              <a:rPr lang="en-US">
+                <a:solidFill>
+                  <a:schemeClr val="tx1"/>
+                </a:solidFill>
+              </a:rPr>
+              <a:t>Ví dụ thực tế</a:t>
+            </a:r>
             <a:endParaRPr lang="en-DE" dirty="0">
               <a:solidFill>
                 <a:schemeClr val="tx1"/>
               </a:solidFill>
             </a:endParaRPr>
-            <a:r>
-              <a:rPr lang="en-US">
-                <a:solidFill>
-                  <a:schemeClr val="tx1"/>
-                </a:solidFill>
-              </a:rPr>
-              <a:t>Ví dụ thực tế</a:t>
-            </a:r>
           </a:p>
         </p:txBody>
       </p:sp>
@@ -20627,11 +20627,11 @@
           <a:bodyPr/>
           <a:lstStyle/>
           <a:p>
+            <a:r>
+              <a:rPr lang="en-US"/>
+              <a:t>4</a:t>
+            </a:r>
             <a:endParaRPr lang="en-DE" dirty="0"/>
-            <a:r>
-              <a:rPr lang="en-US"/>
-              <a:t>4</a:t>
-            </a:r>
           </a:p>
         </p:txBody>
       </p:sp>
@@ -21504,19 +21504,19 @@
           <a:bodyPr/>
           <a:lstStyle/>
           <a:p>
+            <a:r>
+              <a:rPr lang="en-US">
+                <a:solidFill>
+                  <a:schemeClr val="tx1"/>
+                </a:solidFill>
+              </a:rPr>
+              <a:t>Lập trình</a:t>
+            </a:r>
             <a:endParaRPr lang="en-DE" dirty="0">
               <a:solidFill>
                 <a:schemeClr val="tx1"/>
               </a:solidFill>
             </a:endParaRPr>
-            <a:r>
-              <a:rPr lang="en-US">
-                <a:solidFill>
-                  <a:schemeClr val="tx1"/>
-                </a:solidFill>
-              </a:rPr>
-              <a:t>Lập trình</a:t>
-            </a:r>
           </a:p>
         </p:txBody>
       </p:sp>
@@ -21546,11 +21546,11 @@
           <a:bodyPr/>
           <a:lstStyle/>
           <a:p>
+            <a:r>
+              <a:rPr lang="en-US"/>
+              <a:t>5</a:t>
+            </a:r>
             <a:endParaRPr lang="en-DE" dirty="0"/>
-            <a:r>
-              <a:rPr lang="en-US"/>
-              <a:t>5</a:t>
-            </a:r>
           </a:p>
         </p:txBody>
       </p:sp>

</xml_diff>

<commit_message>
Chuyển toàn bộ nội dung deck LPNVi sang tiếng Anh
Chỉ giữ tên sản phẩm ví dụ bằng tiếng Việt vì đó là thứ đang minh họa.
Tên chứng từ dùng tiếng Anh kèm mã: Delivery Note (PGN),
Agent Goods Issue Note (PXKDL), Internal Goods Issue Note (PXKNB).

Co-Authored-By: Claude Opus 5 <noreply@anthropic.com>
Claude-Session: https://claude.ai/code/session_011byrCkBWXeuJWCjrTMvtrk
</commit_message>
<xml_diff>
--- a/slide/LPNVi_LONG_PRODUCTION_NAME_VIETNAMESE.pptx
+++ b/slide/LPNVi_LONG_PRODUCTION_NAME_VIETNAMESE.pptx
@@ -15354,7 +15354,7 @@
                   <a:schemeClr val="tx1"/>
                 </a:solidFill>
               </a:rPr>
-              <a:t>Tổng quan giải pháp</a:t>
+              <a:t>Solution Overview</a:t>
             </a:r>
             <a:endParaRPr lang="en-DE" dirty="0">
               <a:solidFill>
@@ -15993,7 +15993,7 @@
                 </a:solidFill>
                 <a:latin typeface="Calibri"/>
               </a:rPr>
-              <a:t>Ghép Mat. Desc + INSP</a:t>
+              <a:t>Concatenate Mat. Desc + INSP</a:t>
             </a:r>
           </a:p>
         </p:txBody>
@@ -16300,7 +16300,7 @@
                 </a:solidFill>
                 <a:latin typeface="Calibri"/>
               </a:rPr>
-              <a:t>Chứng từ</a:t>
+              <a:t>Warehouse &amp;</a:t>
             </a:r>
             <a:br/>
             <a:r>
@@ -16310,7 +16310,7 @@
                 </a:solidFill>
                 <a:latin typeface="Calibri"/>
               </a:rPr>
-              <a:t>kho / giao nhận</a:t>
+              <a:t>Delivery Notes</a:t>
             </a:r>
           </a:p>
         </p:txBody>
@@ -16652,7 +16652,7 @@
                 </a:solidFill>
                 <a:latin typeface="Calibri"/>
               </a:rPr>
-              <a:t>Hóa đơn</a:t>
+              <a:t>E-Invoice</a:t>
             </a:r>
             <a:br/>
             <a:r>
@@ -16662,7 +16662,7 @@
                 </a:solidFill>
                 <a:latin typeface="Calibri"/>
               </a:rPr>
-              <a:t>điện tử</a:t>
+              <a:t>Display</a:t>
             </a:r>
           </a:p>
         </p:txBody>
@@ -16697,7 +16697,7 @@
                 </a:solidFill>
                 <a:latin typeface="Calibri"/>
               </a:rPr>
-              <a:t>Tách separator "| "</a:t>
+              <a:t>Split on separator "| "</a:t>
             </a:r>
             <a:endParaRPr sz="1050" i="1" dirty="0">
               <a:solidFill>
@@ -16793,7 +16793,7 @@
                 </a:solidFill>
                 <a:latin typeface="Calibri"/>
               </a:rPr>
-              <a:t>Phạm vi: all BU nationwide  —  thứ tự ưu tiên CMIR › MG0156 › INSP.</a:t>
+              <a:t>Scope: all BU nationwide  —  logic priority CMIR › MG0156 › INSP.</a:t>
             </a:r>
           </a:p>
         </p:txBody>
@@ -16914,7 +16914,7 @@
                   <a:schemeClr val="tx1"/>
                 </a:solidFill>
               </a:rPr>
-              <a:t>Hiện trạng</a:t>
+              <a:t>Current Situation</a:t>
             </a:r>
             <a:endParaRPr lang="en-DE" dirty="0">
               <a:solidFill>
@@ -17043,7 +17043,7 @@
                 </a:solidFill>
                 <a:latin typeface="Arial"/>
               </a:rPr>
-              <a:t>Mat. Desc giới hạn 40 ký tự</a:t>
+              <a:t>Mat. Desc is capped at 40 characters</a:t>
             </a:r>
           </a:p>
         </p:txBody>
@@ -17078,7 +17078,7 @@
                 </a:solidFill>
                 <a:latin typeface="Arial"/>
               </a:rPr>
-              <a:t>Tên sản phẩm dài hơn 40 ký tự bị cắt cụt khi in ra chứng từ.</a:t>
+              <a:t>Names longer than 40 characters are truncated on printed documents.</a:t>
             </a:r>
           </a:p>
         </p:txBody>
@@ -17168,7 +17168,7 @@
                 </a:solidFill>
                 <a:latin typeface="Arial"/>
               </a:rPr>
-              <a:t>Đã enhance được một phần</a:t>
+              <a:t>Partly enhanced already</a:t>
             </a:r>
           </a:p>
         </p:txBody>
@@ -17203,7 +17203,7 @@
                 </a:solidFill>
                 <a:latin typeface="Arial"/>
               </a:rPr>
-              <a:t>CMIR cho khách Tender, Basis Text cho nhóm hàng MG0156.</a:t>
+              <a:t>CMIR for Tender customers, Basis Text for material group MG0156.</a:t>
             </a:r>
           </a:p>
         </p:txBody>
@@ -17293,7 +17293,7 @@
                 </a:solidFill>
                 <a:latin typeface="Arial"/>
               </a:rPr>
-              <a:t>Phần còn lại vẫn chưa xử lý</a:t>
+              <a:t>The remaining scope is still open</a:t>
             </a:r>
           </a:p>
         </p:txBody>
@@ -17328,7 +17328,7 @@
                 </a:solidFill>
                 <a:latin typeface="Arial"/>
               </a:rPr>
-              <a:t>Các BU khác chưa in được tên tiếng Việt có dấu, đầy đủ.</a:t>
+              <a:t>Other BUs cannot print the full Vietnamese name with diacritics.</a:t>
             </a:r>
           </a:p>
         </p:txBody>
@@ -17453,7 +17453,7 @@
                 </a:solidFill>
                 <a:latin typeface="Arial"/>
               </a:rPr>
-              <a:t>AS-IS  ·  Tên bị cắt</a:t>
+              <a:t>AS-IS  ·  Name truncated</a:t>
             </a:r>
           </a:p>
         </p:txBody>
@@ -17534,7 +17534,7 @@
                 </a:solidFill>
                 <a:latin typeface="Arial"/>
               </a:rPr>
-              <a:t>Tên đầy đủ cần in</a:t>
+              <a:t>Full name to be printed</a:t>
             </a:r>
           </a:p>
         </p:txBody>
@@ -17624,7 +17624,7 @@
                 </a:solidFill>
                 <a:latin typeface="Arial"/>
               </a:rPr>
-              <a:t>47 KÝ TỰ</a:t>
+              <a:t>47 CHARS</a:t>
             </a:r>
           </a:p>
         </p:txBody>
@@ -17705,7 +17705,7 @@
                 </a:solidFill>
                 <a:latin typeface="Arial"/>
               </a:rPr>
-              <a:t>Mat. Desc chứa được</a:t>
+              <a:t>What Mat. Desc can hold</a:t>
             </a:r>
           </a:p>
         </p:txBody>
@@ -17784,7 +17784,7 @@
                 </a:solidFill>
                 <a:latin typeface="Arial"/>
               </a:rPr>
-              <a:t>không dấu  ·  phần sau bị cắt</a:t>
+              <a:t>no diacritics  ·  rest is cut off</a:t>
             </a:r>
           </a:p>
         </p:txBody>
@@ -17839,7 +17839,7 @@
                 </a:solidFill>
                 <a:latin typeface="Arial"/>
               </a:rPr>
-              <a:t>40 KÝ TỰ</a:t>
+              <a:t>40 CHARS</a:t>
             </a:r>
           </a:p>
         </p:txBody>
@@ -17874,7 +17874,7 @@
                 </a:solidFill>
                 <a:latin typeface="Arial"/>
               </a:rPr>
-              <a:t>→ Hóa đơn / phiếu kho chỉ in được tên tiếng Anh, chưa đủ nghĩa.</a:t>
+              <a:t>→ Invoices and warehouse notes show the English name only.</a:t>
             </a:r>
           </a:p>
         </p:txBody>
@@ -17947,7 +17947,7 @@
                   <a:schemeClr val="tx1"/>
                 </a:solidFill>
               </a:rPr>
-              <a:t>Yêu cầu</a:t>
+              <a:t>Requirement</a:t>
             </a:r>
             <a:endParaRPr lang="en-DE" dirty="0">
               <a:solidFill>
@@ -18076,7 +18076,7 @@
                 </a:solidFill>
                 <a:latin typeface="Arial"/>
               </a:rPr>
-              <a:t>Tên dài, có dấu tiếng Việt</a:t>
+              <a:t>Long name with Vietnamese diacritics</a:t>
             </a:r>
           </a:p>
         </p:txBody>
@@ -18111,7 +18111,7 @@
                 </a:solidFill>
                 <a:latin typeface="Arial"/>
               </a:rPr>
-              <a:t>Vượt giới hạn 40 ký tự của Mat. Desc.</a:t>
+              <a:t>Beyond the 40-character limit of Mat. Desc.</a:t>
             </a:r>
           </a:p>
         </p:txBody>
@@ -18201,7 +18201,7 @@
                 </a:solidFill>
                 <a:latin typeface="Arial"/>
               </a:rPr>
-              <a:t>Trình bày 2 dòng trên hóa đơn</a:t>
+              <a:t>Two lines on the invoice</a:t>
             </a:r>
           </a:p>
         </p:txBody>
@@ -18236,7 +18236,7 @@
                 </a:solidFill>
                 <a:latin typeface="Arial"/>
               </a:rPr>
-              <a:t>Dòng 1 tiếng Việt, dòng 2 tiếng Anh chữ nhỏ hơn trên EIV.</a:t>
+              <a:t>Line 1 Vietnamese, line 2 English in a smaller font on EIV.</a:t>
             </a:r>
           </a:p>
         </p:txBody>
@@ -18326,7 +18326,7 @@
                 </a:solidFill>
                 <a:latin typeface="Arial"/>
               </a:rPr>
-              <a:t>Mở rộng sang chứng từ kho</a:t>
+              <a:t>Extend to warehouse documents</a:t>
             </a:r>
           </a:p>
         </p:txBody>
@@ -18361,7 +18361,7 @@
                 </a:solidFill>
                 <a:latin typeface="Arial"/>
               </a:rPr>
-              <a:t>Phiếu Giao Nhận, Phiếu Xuất Kho Đại Lý, Phiếu Xuất Kho Nội Bộ.</a:t>
+              <a:t>Delivery Note, Agent and Internal Goods Issue Notes.</a:t>
             </a:r>
           </a:p>
         </p:txBody>
@@ -18451,7 +18451,7 @@
                 </a:solidFill>
                 <a:latin typeface="Arial"/>
               </a:rPr>
-              <a:t>Phạm vi áp dụng</a:t>
+              <a:t>Scope</a:t>
             </a:r>
           </a:p>
         </p:txBody>
@@ -18611,7 +18611,7 @@
                 </a:solidFill>
                 <a:latin typeface="Arial"/>
               </a:rPr>
-              <a:t>TO-BE  ·  Hóa đơn điện tử</a:t>
+              <a:t>TO-BE  ·  Electronic invoice</a:t>
             </a:r>
           </a:p>
         </p:txBody>
@@ -18692,7 +18692,7 @@
                 </a:solidFill>
                 <a:latin typeface="Arial"/>
               </a:rPr>
-              <a:t>Tên hàng hóa, dịch vụ</a:t>
+              <a:t>Product / service description</a:t>
             </a:r>
           </a:p>
         </p:txBody>
@@ -18958,7 +18958,7 @@
                 </a:solidFill>
                 <a:latin typeface="Arial"/>
               </a:rPr>
-              <a:t>  Tiếng Việt có dấu — chữ lớn, dòng đầu</a:t>
+              <a:t>  Vietnamese with diacritics — larger, first line</a:t>
             </a:r>
           </a:p>
         </p:txBody>
@@ -19002,7 +19002,7 @@
                 </a:solidFill>
                 <a:latin typeface="Arial"/>
               </a:rPr>
-              <a:t>  Tiếng Anh — chữ nhỏ hơn, dòng dưới</a:t>
+              <a:t>  English — smaller font, second line</a:t>
             </a:r>
           </a:p>
         </p:txBody>
@@ -19037,7 +19037,7 @@
                 </a:solidFill>
                 <a:latin typeface="Arial"/>
               </a:rPr>
-              <a:t>→ Áp dụng cho EIV và cả PGN / PXKDL / PXKNB.</a:t>
+              <a:t>→ Applies to EIV and to PGN / PXKDL / PXKNB.</a:t>
             </a:r>
           </a:p>
         </p:txBody>
@@ -19110,7 +19110,7 @@
                   <a:schemeClr val="tx1"/>
                 </a:solidFill>
               </a:rPr>
-              <a:t>Giải pháp</a:t>
+              <a:t>Solution</a:t>
             </a:r>
             <a:endParaRPr lang="en-DE" dirty="0">
               <a:solidFill>
@@ -19285,7 +19285,7 @@
                 </a:solidFill>
                 <a:latin typeface="Arial"/>
               </a:rPr>
-              <a:t>max 40 ký tự</a:t>
+              <a:t>max 40 chars</a:t>
             </a:r>
           </a:p>
         </p:txBody>
@@ -19320,7 +19320,7 @@
                 </a:solidFill>
                 <a:latin typeface="Arial"/>
               </a:rPr>
-              <a:t>Tên tiếng Anh (default)</a:t>
+              <a:t>English name (default)</a:t>
             </a:r>
           </a:p>
         </p:txBody>
@@ -19456,7 +19456,7 @@
                 </a:solidFill>
                 <a:latin typeface="Arial"/>
               </a:rPr>
-              <a:t>max 220 ký tự</a:t>
+              <a:t>max 220 chars</a:t>
             </a:r>
           </a:p>
         </p:txBody>
@@ -19491,7 +19491,7 @@
                 </a:solidFill>
                 <a:latin typeface="Arial"/>
               </a:rPr>
-              <a:t>Tên tiếng Việt có dấu</a:t>
+              <a:t>Vietnamese name, with diacritics</a:t>
             </a:r>
           </a:p>
         </p:txBody>
@@ -19603,7 +19603,7 @@
                 </a:solidFill>
                 <a:latin typeface="Arial"/>
               </a:rPr>
-              <a:t>nối bằng separator  "| "</a:t>
+              <a:t>joined by separator  "| "</a:t>
             </a:r>
           </a:p>
         </p:txBody>
@@ -19684,7 +19684,7 @@
                 </a:solidFill>
                 <a:latin typeface="Arial"/>
               </a:rPr>
-              <a:t>Chuỗi gửi sang EIV VNPT</a:t>
+              <a:t>String sent to EIV VNPT</a:t>
             </a:r>
           </a:p>
         </p:txBody>
@@ -19772,7 +19772,7 @@
                 </a:solidFill>
                 <a:latin typeface="Arial"/>
               </a:rPr>
-              <a:t>Thứ tự ưu tiên logic</a:t>
+              <a:t>Logic priority</a:t>
             </a:r>
           </a:p>
         </p:txBody>
@@ -19888,7 +19888,7 @@
                 </a:solidFill>
                 <a:latin typeface="Arial"/>
               </a:rPr>
-              <a:t>khách Tender</a:t>
+              <a:t>Tender customers</a:t>
             </a:r>
           </a:p>
         </p:txBody>
@@ -20204,7 +20204,7 @@
                 </a:solidFill>
                 <a:latin typeface="Arial"/>
               </a:rPr>
-              <a:t>phần còn lại</a:t>
+              <a:t>everything else</a:t>
             </a:r>
           </a:p>
         </p:txBody>
@@ -20364,7 +20364,7 @@
                 </a:solidFill>
                 <a:latin typeface="Arial"/>
               </a:rPr>
-              <a:t>INSP chứa được 220 ký tự và giữ nguyên dấu tiếng Việt.</a:t>
+              <a:t>INSP holds 220 characters and keeps Vietnamese diacritics.</a:t>
             </a:r>
           </a:p>
         </p:txBody>
@@ -20441,7 +20441,7 @@
                 </a:solidFill>
                 <a:latin typeface="Arial"/>
               </a:rPr>
-              <a:t>Mat. Desc giữ nguyên như hiện tại — không phải sửa master data cũ.</a:t>
+              <a:t>Mat. Desc stays as it is — no rework on existing master data.</a:t>
             </a:r>
           </a:p>
         </p:txBody>
@@ -20518,7 +20518,7 @@
                 </a:solidFill>
                 <a:latin typeface="Arial"/>
               </a:rPr>
-              <a:t>VNPT tách chuỗi theo "| " để xếp thành 2 dòng trên hóa đơn.</a:t>
+              <a:t>VNPT splits the string on "| " and lays it out on two lines.</a:t>
             </a:r>
           </a:p>
         </p:txBody>
@@ -20591,7 +20591,7 @@
                   <a:schemeClr val="tx1"/>
                 </a:solidFill>
               </a:rPr>
-              <a:t>Ví dụ thực tế</a:t>
+              <a:t>Worked Example</a:t>
             </a:r>
             <a:endParaRPr lang="en-DE" dirty="0">
               <a:solidFill>
@@ -20665,7 +20665,7 @@
                 </a:solidFill>
                 <a:latin typeface="Arial"/>
               </a:rPr>
-              <a:t>Master data nhập vào</a:t>
+              <a:t>Master data entered</a:t>
             </a:r>
           </a:p>
         </p:txBody>
@@ -20932,7 +20932,7 @@
                 </a:solidFill>
                 <a:latin typeface="Arial"/>
               </a:rPr>
-              <a:t>Chuỗi SAP ghép và gửi sang EIV</a:t>
+              <a:t>String SAP builds and sends to EIV</a:t>
             </a:r>
           </a:p>
         </p:txBody>
@@ -21066,7 +21066,7 @@
                 </a:solidFill>
                 <a:latin typeface="Arial"/>
               </a:rPr>
-              <a:t>● Mat. Desc — tiếng Anh</a:t>
+              <a:t>● Mat. Desc — English</a:t>
             </a:r>
             <a:r>
               <a:rPr sz="950" b="1">
@@ -21084,7 +21084,7 @@
                 </a:solidFill>
                 <a:latin typeface="Arial"/>
               </a:rPr>
-              <a:t>      ● INSP — tiếng Việt có dấu</a:t>
+              <a:t>      ● INSP — Vietnamese with diacritics</a:t>
             </a:r>
           </a:p>
         </p:txBody>
@@ -21119,7 +21119,7 @@
                 </a:solidFill>
                 <a:latin typeface="Arial"/>
               </a:rPr>
-              <a:t>Kết quả trình bày trên hóa đơn / phiếu kho</a:t>
+              <a:t>How it prints on the invoice / warehouse note</a:t>
             </a:r>
           </a:p>
         </p:txBody>
@@ -21325,7 +21325,7 @@
                 </a:solidFill>
                 <a:latin typeface="Arial"/>
               </a:rPr>
-              <a:t>Tên hàng hóa, dịch vụ</a:t>
+              <a:t>Product / service description</a:t>
             </a:r>
           </a:p>
         </p:txBody>
@@ -21510,7 +21510,7 @@
                   <a:schemeClr val="tx1"/>
                 </a:solidFill>
               </a:rPr>
-              <a:t>Lập trình</a:t>
+              <a:t>Development</a:t>
             </a:r>
             <a:endParaRPr lang="en-DE" dirty="0">
               <a:solidFill>
@@ -21861,7 +21861,7 @@
                 </a:solidFill>
                 <a:latin typeface="Arial"/>
               </a:rPr>
-              <a:t>Ghép Mat. Desc + INSP text</a:t>
+              <a:t>Concatenate Mat. Desc + INSP text</a:t>
             </a:r>
           </a:p>
         </p:txBody>
@@ -21951,7 +21951,7 @@
                 </a:solidFill>
                 <a:latin typeface="Arial"/>
               </a:rPr>
-              <a:t>Chèn separator "| "</a:t>
+              <a:t>Insert separator "| "</a:t>
             </a:r>
           </a:p>
         </p:txBody>
@@ -22041,7 +22041,7 @@
                 </a:solidFill>
                 <a:latin typeface="Arial"/>
               </a:rPr>
-              <a:t>Áp thứ tự CMIR › MG0156 › INSP</a:t>
+              <a:t>Apply priority CMIR › MG0156 › INSP</a:t>
             </a:r>
           </a:p>
         </p:txBody>
@@ -22221,7 +22221,7 @@
                 </a:solidFill>
                 <a:latin typeface="Arial"/>
               </a:rPr>
-              <a:t>Form chứng từ kho</a:t>
+              <a:t>Warehouse &amp; delivery forms</a:t>
             </a:r>
           </a:p>
         </p:txBody>
@@ -22353,7 +22353,7 @@
                 </a:solidFill>
                 <a:latin typeface="Arial"/>
               </a:rPr>
-              <a:t>Phiếu Giao Nhận (PGN)</a:t>
+              <a:t>Delivery Note (PGN)</a:t>
             </a:r>
           </a:p>
         </p:txBody>
@@ -22443,7 +22443,7 @@
                 </a:solidFill>
                 <a:latin typeface="Arial"/>
               </a:rPr>
-              <a:t>Phiếu Xuất Kho Đại Lý (PXKDL)</a:t>
+              <a:t>Agent Goods Issue Note (PXKDL)</a:t>
             </a:r>
           </a:p>
         </p:txBody>
@@ -22533,7 +22533,7 @@
                 </a:solidFill>
                 <a:latin typeface="Arial"/>
               </a:rPr>
-              <a:t>Phiếu Xuất Kho Nội Bộ (PXKNB)</a:t>
+              <a:t>Internal Goods Issue Note (PXKNB)</a:t>
             </a:r>
           </a:p>
         </p:txBody>
@@ -22713,7 +22713,7 @@
                 </a:solidFill>
                 <a:latin typeface="Arial"/>
               </a:rPr>
-              <a:t>Hóa đơn điện tử EIV</a:t>
+              <a:t>E-invoice (EIV)</a:t>
             </a:r>
           </a:p>
         </p:txBody>
@@ -22845,7 +22845,7 @@
                 </a:solidFill>
                 <a:latin typeface="Arial"/>
               </a:rPr>
-              <a:t>Nhận biết separator "| "</a:t>
+              <a:t>Detect the separator "| "</a:t>
             </a:r>
           </a:p>
         </p:txBody>
@@ -22935,7 +22935,7 @@
                 </a:solidFill>
                 <a:latin typeface="Arial"/>
               </a:rPr>
-              <a:t>Tách thành 2 dòng</a:t>
+              <a:t>Split into two lines</a:t>
             </a:r>
           </a:p>
         </p:txBody>
@@ -23025,7 +23025,7 @@
                 </a:solidFill>
                 <a:latin typeface="Arial"/>
               </a:rPr>
-              <a:t>Tiếng Anh cỡ chữ nhỏ hơn</a:t>
+              <a:t>English in a smaller font</a:t>
             </a:r>
           </a:p>
         </p:txBody>
@@ -23060,7 +23060,7 @@
                 </a:solidFill>
                 <a:latin typeface="Arial"/>
               </a:rPr>
-              <a:t>Ba nhánh chạy song song — master data setup xong trước khi go-live.</a:t>
+              <a:t>Three parallel workstreams — master data setup must be done before go-live.</a:t>
             </a:r>
           </a:p>
         </p:txBody>
@@ -23131,7 +23131,7 @@
           <a:p>
             <a:r>
               <a:rPr lang="en-US"/>
-              <a:t>Tóm lại</a:t>
+              <a:t>Summary</a:t>
             </a:r>
           </a:p>
         </p:txBody>
@@ -23264,7 +23264,7 @@
                     <a:p>
                       <a:r>
                         <a:rPr lang="en-US" sz="2000"/>
-                        <a:t>Nội dung</a:t>
+                        <a:t>Item</a:t>
                       </a:r>
                     </a:p>
                   </a:txBody>
@@ -23277,7 +23277,7 @@
                     <a:p>
                       <a:r>
                         <a:rPr lang="en-US" sz="2000"/>
-                        <a:t>Ai làm</a:t>
+                        <a:t>Owner</a:t>
                       </a:r>
                     </a:p>
                   </a:txBody>
@@ -23290,7 +23290,7 @@
                     <a:p>
                       <a:r>
                         <a:rPr lang="en-US" sz="2000"/>
-                        <a:t>Trạng thái</a:t>
+                        <a:t>Status</a:t>
                       </a:r>
                     </a:p>
                   </a:txBody>
@@ -23323,7 +23323,7 @@
                     <a:p>
                       <a:r>
                         <a:rPr lang="en-US" sz="1800"/>
-                        <a:t>Phạm vi: all BU nationwide</a:t>
+                        <a:t>Scope: all BU nationwide</a:t>
                       </a:r>
                     </a:p>
                   </a:txBody>
@@ -23353,7 +23353,7 @@
                             <a:srgbClr val="BE0028"/>
                           </a:solidFill>
                         </a:rPr>
-                        <a:t>Đã chốt</a:t>
+                        <a:t>Confirmed</a:t>
                       </a:r>
                     </a:p>
                   </a:txBody>
@@ -23449,7 +23449,7 @@
                     <a:p>
                       <a:r>
                         <a:rPr lang="en-US" sz="1800"/>
-                        <a:t>Ưu tiên: CMIR › MG0156 › INSP</a:t>
+                        <a:t>Priority: CMIR › MG0156 › INSP</a:t>
                       </a:r>
                     </a:p>
                   </a:txBody>
@@ -23479,7 +23479,7 @@
                             <a:srgbClr val="BE0028"/>
                           </a:solidFill>
                         </a:rPr>
-                        <a:t>Lập trình</a:t>
+                        <a:t>Develop</a:t>
                       </a:r>
                     </a:p>
                   </a:txBody>
@@ -23512,7 +23512,7 @@
                     <a:p>
                       <a:r>
                         <a:rPr lang="en-US" sz="1800"/>
-                        <a:t>Dentsply: xóa hết record CMIR trước</a:t>
+                        <a:t>Dentsply: remove all CMIR records first</a:t>
                       </a:r>
                     </a:p>
                   </a:txBody>
@@ -23542,7 +23542,7 @@
                             <a:srgbClr val="6B6B6B"/>
                           </a:solidFill>
                         </a:rPr>
-                        <a:t>Lưu ý</a:t>
+                        <a:t>Action</a:t>
                       </a:r>
                     </a:p>
                   </a:txBody>

</xml_diff>